<commit_message>
Boubacar LinkedIn option E: gold root-network card (Roboto + Times New Roman) with his cutout
Co-Authored-By: Claude Opus 5.5 <noreply@anthropic.com>
Claude-Session: https://claude.ai/code/session_014HGzAbxBh54nuyJHG7tse8
</commit_message>
<xml_diff>
--- a/templates/posts/october/01-10-2026-thu-li-boubacar-option-d-journal.pptx
+++ b/templates/posts/october/01-10-2026-thu-li-boubacar-option-d-journal.pptx
@@ -3518,7 +3518,7 @@
       <p:grpSpPr/>
       <p:pic>
         <p:nvPicPr>
-          <p:cNvPr id="2" name="Picture 1" descr="5005862133392725016.jpg"/>
+          <p:cNvPr id="2" name="Picture 1" descr="2482962135540615685.jpg"/>
           <p:cNvPicPr>
             <a:picLocks noChangeAspect="1"/>
           </p:cNvPicPr>
@@ -3586,7 +3586,7 @@
       </p:sp>
       <p:pic>
         <p:nvPicPr>
-          <p:cNvPr id="4" name="Picture 3" descr="7761561938347265586.jpg"/>
+          <p:cNvPr id="4" name="Picture 3" descr="8825506431498531566.jpg"/>
           <p:cNvPicPr>
             <a:picLocks noChangeAspect="1"/>
           </p:cNvPicPr>
@@ -3610,7 +3610,7 @@
       </p:pic>
       <p:pic>
         <p:nvPicPr>
-          <p:cNvPr id="5" name="Picture 4" descr="573726833258093952.jpg"/>
+          <p:cNvPr id="5" name="Picture 4" descr="7686165524063948698.jpg"/>
           <p:cNvPicPr>
             <a:picLocks noChangeAspect="1"/>
           </p:cNvPicPr>

</xml_diff>

<commit_message>
Boubacar LinkedIn option E: cutout from the vegetable-beds photo
Co-Authored-By: Claude Opus 5.5 <noreply@anthropic.com>
Claude-Session: https://claude.ai/code/session_014HGzAbxBh54nuyJHG7tse8
</commit_message>
<xml_diff>
--- a/templates/posts/october/01-10-2026-thu-li-boubacar-option-d-journal.pptx
+++ b/templates/posts/october/01-10-2026-thu-li-boubacar-option-d-journal.pptx
@@ -3518,7 +3518,7 @@
       <p:grpSpPr/>
       <p:pic>
         <p:nvPicPr>
-          <p:cNvPr id="2" name="Picture 1" descr="2482962135540615685.jpg"/>
+          <p:cNvPr id="2" name="Picture 1" descr="8417339178458094803.jpg"/>
           <p:cNvPicPr>
             <a:picLocks noChangeAspect="1"/>
           </p:cNvPicPr>
@@ -3586,7 +3586,7 @@
       </p:sp>
       <p:pic>
         <p:nvPicPr>
-          <p:cNvPr id="4" name="Picture 3" descr="8825506431498531566.jpg"/>
+          <p:cNvPr id="4" name="Picture 3" descr="4433374347225538468.jpg"/>
           <p:cNvPicPr>
             <a:picLocks noChangeAspect="1"/>
           </p:cNvPicPr>
@@ -3610,7 +3610,7 @@
       </p:pic>
       <p:pic>
         <p:nvPicPr>
-          <p:cNvPr id="5" name="Picture 4" descr="7686165524063948698.jpg"/>
+          <p:cNvPr id="5" name="Picture 4" descr="2751125157360117170.jpg"/>
           <p:cNvPicPr>
             <a:picLocks noChangeAspect="1"/>
           </p:cNvPicPr>

</xml_diff>

<commit_message>
Boubacar LinkedIn option E: sharp full-resolution portrait in an arch frame instead of the soft cutout
Co-Authored-By: Claude Opus 5.5 <noreply@anthropic.com>
Claude-Session: https://claude.ai/code/session_014HGzAbxBh54nuyJHG7tse8
</commit_message>
<xml_diff>
--- a/templates/posts/october/01-10-2026-thu-li-boubacar-option-d-journal.pptx
+++ b/templates/posts/october/01-10-2026-thu-li-boubacar-option-d-journal.pptx
@@ -3518,7 +3518,7 @@
       <p:grpSpPr/>
       <p:pic>
         <p:nvPicPr>
-          <p:cNvPr id="2" name="Picture 1" descr="8417339178458094803.jpg"/>
+          <p:cNvPr id="2" name="Picture 1" descr="4463738093408743979.jpg"/>
           <p:cNvPicPr>
             <a:picLocks noChangeAspect="1"/>
           </p:cNvPicPr>
@@ -3586,7 +3586,7 @@
       </p:sp>
       <p:pic>
         <p:nvPicPr>
-          <p:cNvPr id="4" name="Picture 3" descr="4433374347225538468.jpg"/>
+          <p:cNvPr id="4" name="Picture 3" descr="7985378975865230690.jpg"/>
           <p:cNvPicPr>
             <a:picLocks noChangeAspect="1"/>
           </p:cNvPicPr>
@@ -3610,7 +3610,7 @@
       </p:pic>
       <p:pic>
         <p:nvPicPr>
-          <p:cNvPr id="5" name="Picture 4" descr="2751125157360117170.jpg"/>
+          <p:cNvPr id="5" name="Picture 4" descr="1696654848631023207.jpg"/>
           <p:cNvPicPr>
             <a:picLocks noChangeAspect="1"/>
           </p:cNvPicPr>

</xml_diff>

<commit_message>
Boubacar LinkedIn option E in green with a green root network
Co-Authored-By: Claude Opus 5.5 <noreply@anthropic.com>
Claude-Session: https://claude.ai/code/session_014HGzAbxBh54nuyJHG7tse8
</commit_message>
<xml_diff>
--- a/templates/posts/october/01-10-2026-thu-li-boubacar-option-d-journal.pptx
+++ b/templates/posts/october/01-10-2026-thu-li-boubacar-option-d-journal.pptx
@@ -3518,7 +3518,7 @@
       <p:grpSpPr/>
       <p:pic>
         <p:nvPicPr>
-          <p:cNvPr id="2" name="Picture 1" descr="4463738093408743979.jpg"/>
+          <p:cNvPr id="2" name="Picture 1" descr="5620218793020029425.jpg"/>
           <p:cNvPicPr>
             <a:picLocks noChangeAspect="1"/>
           </p:cNvPicPr>
@@ -3586,7 +3586,7 @@
       </p:sp>
       <p:pic>
         <p:nvPicPr>
-          <p:cNvPr id="4" name="Picture 3" descr="7985378975865230690.jpg"/>
+          <p:cNvPr id="4" name="Picture 3" descr="2740096219490858533.jpg"/>
           <p:cNvPicPr>
             <a:picLocks noChangeAspect="1"/>
           </p:cNvPicPr>
@@ -3610,7 +3610,7 @@
       </p:pic>
       <p:pic>
         <p:nvPicPr>
-          <p:cNvPr id="5" name="Picture 4" descr="1696654848631023207.jpg"/>
+          <p:cNvPr id="5" name="Picture 4" descr="5854303894922181250.jpg"/>
           <p:cNvPicPr>
             <a:picLocks noChangeAspect="1"/>
           </p:cNvPicPr>

</xml_diff>

<commit_message>
Boubacar: brand fonts (Montserrat, EB Garamond) on the roots carousel and LinkedIn option E; bigger soilfoodweb.com footer
Co-Authored-By: Claude Opus 5.5 <noreply@anthropic.com>
Claude-Session: https://claude.ai/code/session_014HGzAbxBh54nuyJHG7tse8
</commit_message>
<xml_diff>
--- a/templates/posts/october/01-10-2026-thu-li-boubacar-option-d-journal.pptx
+++ b/templates/posts/october/01-10-2026-thu-li-boubacar-option-d-journal.pptx
@@ -3518,7 +3518,7 @@
       <p:grpSpPr/>
       <p:pic>
         <p:nvPicPr>
-          <p:cNvPr id="2" name="Picture 1" descr="5620218793020029425.jpg"/>
+          <p:cNvPr id="2" name="Picture 1" descr="1350040564651231542.jpg"/>
           <p:cNvPicPr>
             <a:picLocks noChangeAspect="1"/>
           </p:cNvPicPr>
@@ -3586,7 +3586,7 @@
       </p:sp>
       <p:pic>
         <p:nvPicPr>
-          <p:cNvPr id="4" name="Picture 3" descr="2740096219490858533.jpg"/>
+          <p:cNvPr id="4" name="Picture 3" descr="1272484763129762532.jpg"/>
           <p:cNvPicPr>
             <a:picLocks noChangeAspect="1"/>
           </p:cNvPicPr>
@@ -3610,7 +3610,7 @@
       </p:pic>
       <p:pic>
         <p:nvPicPr>
-          <p:cNvPr id="5" name="Picture 4" descr="5854303894922181250.jpg"/>
+          <p:cNvPr id="5" name="Picture 4" descr="1769236491898131610.jpg"/>
           <p:cNvPicPr>
             <a:picLocks noChangeAspect="1"/>
           </p:cNvPicPr>

</xml_diff>